<commit_message>
Update PPTX template to modelo final (2 slides) and update NRs content
</commit_message>
<xml_diff>
--- a/test_output.pptx
+++ b/test_output.pptx
@@ -5,40 +5,38 @@
     <p:sldMasterId id="2147483659" r:id="rId1"/>
   </p:sldMasterIdLst>
   <p:notesMasterIdLst>
-    <p:notesMasterId r:id="rId30"/>
+    <p:notesMasterId r:id="rId4"/>
   </p:notesMasterIdLst>
   <p:handoutMasterIdLst>
-    <p:handoutMasterId r:id="rId31"/>
+    <p:handoutMasterId r:id="rId5"/>
   </p:handoutMasterIdLst>
   <p:sldIdLst>
     <p:sldId id="400" r:id="rId100"/>
     <p:sldId id="401" r:id="rId101"/>
-    <p:sldId id="402" r:id="rId102"/>
-    <p:sldId id="403" r:id="rId103"/>
   </p:sldIdLst>
   <p:sldSz cx="33413700" cy="23622000"/>
   <p:notesSz cx="6858000" cy="9144000"/>
   <p:embeddedFontLst>
     <p:embeddedFont>
+      <p:font typeface="Montserrat" panose="020B0604020202020204" charset="0"/>
+      <p:regular r:id="rId6"/>
+      <p:bold r:id="rId7"/>
+      <p:italic r:id="rId8"/>
+      <p:boldItalic r:id="rId9"/>
+    </p:embeddedFont>
+    <p:embeddedFont>
       <p:font typeface="Calibri" panose="020F0502020204030204" pitchFamily="34" charset="0"/>
-      <p:regular r:id="rId32"/>
-      <p:bold r:id="rId33"/>
-      <p:italic r:id="rId34"/>
-      <p:boldItalic r:id="rId35"/>
+      <p:regular r:id="rId10"/>
+      <p:bold r:id="rId11"/>
+      <p:italic r:id="rId12"/>
+      <p:boldItalic r:id="rId13"/>
     </p:embeddedFont>
     <p:embeddedFont>
       <p:font typeface="Montserrat SemiBold" panose="020B0604020202020204" charset="0"/>
-      <p:regular r:id="rId36"/>
-      <p:bold r:id="rId37"/>
-      <p:italic r:id="rId38"/>
-      <p:boldItalic r:id="rId39"/>
-    </p:embeddedFont>
-    <p:embeddedFont>
-      <p:font typeface="Montserrat" panose="020B0604020202020204" charset="0"/>
-      <p:regular r:id="rId40"/>
-      <p:bold r:id="rId41"/>
-      <p:italic r:id="rId42"/>
-      <p:boldItalic r:id="rId43"/>
+      <p:regular r:id="rId14"/>
+      <p:bold r:id="rId15"/>
+      <p:italic r:id="rId16"/>
+      <p:boldItalic r:id="rId17"/>
     </p:embeddedFont>
   </p:embeddedFontLst>
   <p:defaultTextStyle>
@@ -10729,7 +10727,7 @@
     <p:bg>
       <p:bgPr>
         <a:blipFill>
-          <a:blip r:embed="rId3">
+          <a:blip r:embed="rId2">
             <a:alphaModFix/>
           </a:blip>
           <a:stretch>
@@ -10822,8 +10820,8 @@
         </p:nvSpPr>
         <p:spPr>
           <a:xfrm>
-            <a:off x="7207875" y="11019546"/>
-            <a:ext cx="20103136" cy="1723549"/>
+            <a:off x="5802818" y="11282255"/>
+            <a:ext cx="21975097" cy="1163395"/>
           </a:xfrm>
           <a:prstGeom prst="rect">
             <a:avLst/>
@@ -10854,7 +10852,7 @@
                 <a:cs typeface="Montserrat"/>
                 <a:sym typeface="Montserrat"/>
               </a:rPr>
-              <a:t>Sobre uso e guarda de EPI conforme exigências da </a:t>
+              <a:t>Sobre uso e guarda de EPI conforme exigências da Norma Regulamentadora - NR 06</a:t>
             </a:r>
           </a:p>
           <a:p>
@@ -10863,18 +10861,6 @@
                 <a:spcPct val="139988"/>
               </a:lnSpc>
             </a:pPr>
-            <a:r>
-              <a:rPr lang="pt-BR" sz="4000" b="1" dirty="0">
-                <a:solidFill>
-                  <a:schemeClr val="tx1"/>
-                </a:solidFill>
-                <a:latin typeface="Montserrat"/>
-                <a:ea typeface="Montserrat"/>
-                <a:cs typeface="Montserrat"/>
-                <a:sym typeface="Montserrat"/>
-              </a:rPr>
-              <a:t>Norma Regulamentadora - NR 06</a:t>
-            </a:r>
             <a:endParaRPr dirty="0"/>
           </a:p>
         </p:txBody>
@@ -10887,7 +10873,7 @@
         </p:nvSpPr>
         <p:spPr>
           <a:xfrm>
-            <a:off x="7207875" y="14733100"/>
+            <a:off x="6296211" y="14634995"/>
             <a:ext cx="5264700" cy="492600"/>
           </a:xfrm>
           <a:prstGeom prst="rect">
@@ -10945,7 +10931,7 @@
         </p:nvSpPr>
         <p:spPr>
           <a:xfrm>
-            <a:off x="12772752" y="14617541"/>
+            <a:off x="12173529" y="14660478"/>
             <a:ext cx="5264700" cy="492600"/>
           </a:xfrm>
           <a:prstGeom prst="rect">
@@ -11003,8 +10989,8 @@
         </p:nvSpPr>
         <p:spPr>
           <a:xfrm>
-            <a:off x="19607362" y="14617541"/>
-            <a:ext cx="9299100" cy="492600"/>
+            <a:off x="18258503" y="14660478"/>
+            <a:ext cx="9091444" cy="467117"/>
           </a:xfrm>
           <a:prstGeom prst="rect">
             <a:avLst/>
@@ -11109,7 +11095,7 @@
               </a:rPr>
             </a:br>
             <a:r>
-              <a:rPr lang="en-US" sz="3200" b="1" dirty="0">
+              <a:rPr lang="en-US" sz="3200" b="1" dirty="0" smtClean="0">
                 <a:solidFill>
                   <a:schemeClr val="tx1">
                     <a:lumMod val="85000"/>
@@ -11123,7 +11109,7 @@
               <a:t>CPF:</a:t>
             </a:r>
             <a:r>
-              <a:rPr lang="en-US" sz="3200" b="1" dirty="0">
+              <a:rPr lang="en-US" sz="3200" b="1" dirty="0" smtClean="0">
                 <a:solidFill>
                   <a:schemeClr val="tx1">
                     <a:lumMod val="85000"/>
@@ -11144,400 +11130,15 @@
           </a:p>
         </p:txBody>
       </p:sp>
-      <p:pic>
-        <p:nvPicPr>
-          <p:cNvPr id="2" name="Imagem 1"/>
-          <p:cNvPicPr>
-            <a:picLocks noChangeAspect="1"/>
-          </p:cNvPicPr>
-          <p:nvPr/>
-        </p:nvPicPr>
-        <p:blipFill>
-          <a:blip r:embed="rId4">
-            <a:extLst>
-              <a:ext uri="{28A0092B-C50C-407E-A947-70E740481C1C}">
-                <a14:useLocalDpi xmlns:a14="http://schemas.microsoft.com/office/drawing/2010/main" val="0"/>
-              </a:ext>
-            </a:extLst>
-          </a:blip>
-          <a:stretch>
-            <a:fillRect/>
-          </a:stretch>
-        </p:blipFill>
-        <p:spPr>
-          <a:xfrm>
-            <a:off x="19607362" y="18859033"/>
-            <a:ext cx="6003305" cy="2357662"/>
-          </a:xfrm>
-          <a:prstGeom prst="rect">
-            <a:avLst/>
-          </a:prstGeom>
-        </p:spPr>
-      </p:pic>
-    </p:spTree>
-    <p:extLst>
-      <p:ext uri="{BB962C8B-B14F-4D97-AF65-F5344CB8AC3E}">
-        <p14:creationId xmlns:p14="http://schemas.microsoft.com/office/powerpoint/2010/main" val="1304343074"/>
-      </p:ext>
-    </p:extLst>
-  </p:cSld>
-  <p:clrMapOvr>
-    <a:masterClrMapping/>
-  </p:clrMapOvr>
-</p:sld>
-</file>
-
-<file path=ppt/slides/slide2.xml><?xml version="1.0" encoding="utf-8"?>
-<p:sld xmlns:a="http://schemas.openxmlformats.org/drawingml/2006/main" xmlns:r="http://schemas.openxmlformats.org/officeDocument/2006/relationships" xmlns:p="http://schemas.openxmlformats.org/presentationml/2006/main">
-  <p:cSld>
-    <p:bg>
-      <p:bgPr>
-        <a:blipFill>
-          <a:blip r:embed="rId3">
-            <a:alphaModFix/>
-          </a:blip>
-          <a:stretch>
-            <a:fillRect/>
-          </a:stretch>
-        </a:blipFill>
-        <a:effectLst/>
-      </p:bgPr>
-    </p:bg>
-    <p:spTree>
-      <p:nvGrpSpPr>
-        <p:cNvPr id="1" name="Shape 83"/>
-        <p:cNvGrpSpPr/>
-        <p:nvPr/>
-      </p:nvGrpSpPr>
-      <p:grpSpPr>
-        <a:xfrm>
-          <a:off x="0" y="0"/>
-          <a:ext cx="0" cy="0"/>
-          <a:chOff x="0" y="0"/>
-          <a:chExt cx="0" cy="0"/>
-        </a:xfrm>
-      </p:grpSpPr>
       <p:sp>
         <p:nvSpPr>
-          <p:cNvPr id="84" name="Google Shape;84;p13"/>
+          <p:cNvPr id="9" name="Google Shape;91;p13"/>
           <p:cNvSpPr txBox="1"/>
           <p:nvPr/>
         </p:nvSpPr>
         <p:spPr>
           <a:xfrm>
-            <a:off x="7970067" y="7700537"/>
-            <a:ext cx="17640600" cy="1013675"/>
-          </a:xfrm>
-          <a:prstGeom prst="rect">
-            <a:avLst/>
-          </a:prstGeom>
-          <a:noFill/>
-          <a:ln>
-            <a:noFill/>
-          </a:ln>
-        </p:spPr>
-        <p:txBody>
-          <a:bodyPr spcFirstLastPara="1" wrap="square" lIns="0" tIns="0" rIns="0" bIns="0" anchor="t" anchorCtr="0">
-            <a:spAutoFit/>
-          </a:bodyPr>
-          <a:lstStyle/>
-          <a:p>
-            <a:pPr marL="0" marR="0" lvl="0" indent="0" algn="ctr" rtl="0">
-              <a:lnSpc>
-                <a:spcPct val="140021"/>
-              </a:lnSpc>
-              <a:spcBef>
-                <a:spcPts val="0"/>
-              </a:spcBef>
-              <a:spcAft>
-                <a:spcPts val="0"/>
-              </a:spcAft>
-              <a:buNone/>
-            </a:pPr>
-            <a:r>
-              <a:rPr lang="en-US" sz="4705" b="1" dirty="0">
-                <a:solidFill>
-                  <a:schemeClr val="dk1"/>
-                </a:solidFill>
-                <a:latin typeface="Montserrat"/>
-                <a:ea typeface="Montserrat"/>
-                <a:cs typeface="Montserrat"/>
-                <a:sym typeface="Montserrat"/>
-              </a:rPr>
-              <a:t>João da Silva Santos </a:t>
-            </a:r>
-            <a:r>
-              <a:rPr lang="en-US" sz="4705" b="1" dirty="0" err="1">
-                <a:solidFill>
-                  <a:schemeClr val="dk1"/>
-                </a:solidFill>
-                <a:latin typeface="Montserrat"/>
-                <a:ea typeface="Montserrat"/>
-                <a:cs typeface="Montserrat"/>
-                <a:sym typeface="Montserrat"/>
-              </a:rPr>
-              <a:t/>
-            </a:r>
-            <a:r>
-              <a:rPr lang="en-US" sz="4705" b="1" dirty="0">
-                <a:solidFill>
-                  <a:schemeClr val="dk1"/>
-                </a:solidFill>
-                <a:latin typeface="Montserrat"/>
-                <a:ea typeface="Montserrat"/>
-                <a:cs typeface="Montserrat"/>
-                <a:sym typeface="Montserrat"/>
-              </a:rPr>
-              <a:t/>
-            </a:r>
-            <a:endParaRPr lang="en-US" sz="4800" b="1" dirty="0">
-              <a:solidFill>
-                <a:schemeClr val="dk1"/>
-              </a:solidFill>
-              <a:latin typeface="Montserrat"/>
-              <a:ea typeface="Montserrat"/>
-              <a:cs typeface="Montserrat"/>
-              <a:sym typeface="Montserrat"/>
-            </a:endParaRPr>
-          </a:p>
-        </p:txBody>
-      </p:sp>
-      <p:sp>
-        <p:nvSpPr>
-          <p:cNvPr id="86" name="Google Shape;86;p13"/>
-          <p:cNvSpPr txBox="1"/>
-          <p:nvPr/>
-        </p:nvSpPr>
-        <p:spPr>
-          <a:xfrm>
-            <a:off x="7207875" y="11019546"/>
-            <a:ext cx="20103136" cy="1723549"/>
-          </a:xfrm>
-          <a:prstGeom prst="rect">
-            <a:avLst/>
-          </a:prstGeom>
-          <a:noFill/>
-          <a:ln>
-            <a:noFill/>
-          </a:ln>
-        </p:spPr>
-        <p:txBody>
-          <a:bodyPr spcFirstLastPara="1" wrap="square" lIns="0" tIns="0" rIns="0" bIns="0" anchor="t" anchorCtr="0">
-            <a:spAutoFit/>
-          </a:bodyPr>
-          <a:lstStyle/>
-          <a:p>
-            <a:pPr algn="ctr">
-              <a:lnSpc>
-                <a:spcPct val="139988"/>
-              </a:lnSpc>
-            </a:pPr>
-            <a:r>
-              <a:rPr lang="pt-BR" sz="4000" b="1" dirty="0">
-                <a:solidFill>
-                  <a:schemeClr val="tx1"/>
-                </a:solidFill>
-                <a:latin typeface="Montserrat"/>
-                <a:ea typeface="Montserrat"/>
-                <a:cs typeface="Montserrat"/>
-                <a:sym typeface="Montserrat"/>
-              </a:rPr>
-              <a:t>Sobre uso e guarda de EPI conforme exigências da </a:t>
-            </a:r>
-          </a:p>
-          <a:p>
-            <a:pPr algn="ctr">
-              <a:lnSpc>
-                <a:spcPct val="139988"/>
-              </a:lnSpc>
-            </a:pPr>
-            <a:r>
-              <a:rPr lang="pt-BR" sz="4000" b="1" dirty="0">
-                <a:solidFill>
-                  <a:schemeClr val="tx1"/>
-                </a:solidFill>
-                <a:latin typeface="Montserrat"/>
-                <a:ea typeface="Montserrat"/>
-                <a:cs typeface="Montserrat"/>
-                <a:sym typeface="Montserrat"/>
-              </a:rPr>
-              <a:t>Norma Regulamentadora - NR 06</a:t>
-            </a:r>
-            <a:endParaRPr dirty="0"/>
-          </a:p>
-        </p:txBody>
-      </p:sp>
-      <p:sp>
-        <p:nvSpPr>
-          <p:cNvPr id="87" name="Google Shape;87;p13"/>
-          <p:cNvSpPr txBox="1"/>
-          <p:nvPr/>
-        </p:nvSpPr>
-        <p:spPr>
-          <a:xfrm>
-            <a:off x="7207875" y="14733100"/>
-            <a:ext cx="5264700" cy="492600"/>
-          </a:xfrm>
-          <a:prstGeom prst="rect">
-            <a:avLst/>
-          </a:prstGeom>
-          <a:noFill/>
-          <a:ln>
-            <a:noFill/>
-          </a:ln>
-        </p:spPr>
-        <p:txBody>
-          <a:bodyPr spcFirstLastPara="1" wrap="square" lIns="0" tIns="0" rIns="0" bIns="0" anchor="ctr" anchorCtr="0">
-            <a:noAutofit/>
-          </a:bodyPr>
-          <a:lstStyle/>
-          <a:p>
-            <a:pPr marL="0" marR="0" lvl="0" indent="0" algn="l" rtl="0">
-              <a:lnSpc>
-                <a:spcPct val="139980"/>
-              </a:lnSpc>
-              <a:spcBef>
-                <a:spcPts val="0"/>
-              </a:spcBef>
-              <a:spcAft>
-                <a:spcPts val="0"/>
-              </a:spcAft>
-              <a:buNone/>
-            </a:pPr>
-            <a:r>
-              <a:rPr lang="en-US" sz="3200" dirty="0">
-                <a:solidFill>
-                  <a:srgbClr val="0E0E0E"/>
-                </a:solidFill>
-                <a:latin typeface="Montserrat"/>
-                <a:ea typeface="Montserrat"/>
-                <a:cs typeface="Montserrat"/>
-                <a:sym typeface="Montserrat"/>
-              </a:rPr>
-              <a:t>07/08/2026</a:t>
-            </a:r>
-            <a:endParaRPr sz="3200" dirty="0">
-              <a:latin typeface="Montserrat"/>
-              <a:ea typeface="Montserrat"/>
-              <a:cs typeface="Montserrat"/>
-              <a:sym typeface="Montserrat"/>
-            </a:endParaRPr>
-          </a:p>
-        </p:txBody>
-      </p:sp>
-      <p:sp>
-        <p:nvSpPr>
-          <p:cNvPr id="88" name="Google Shape;88;p13"/>
-          <p:cNvSpPr txBox="1"/>
-          <p:nvPr/>
-        </p:nvSpPr>
-        <p:spPr>
-          <a:xfrm>
-            <a:off x="12472575" y="14617541"/>
-            <a:ext cx="5264700" cy="492600"/>
-          </a:xfrm>
-          <a:prstGeom prst="rect">
-            <a:avLst/>
-          </a:prstGeom>
-          <a:noFill/>
-          <a:ln>
-            <a:noFill/>
-          </a:ln>
-        </p:spPr>
-        <p:txBody>
-          <a:bodyPr spcFirstLastPara="1" wrap="square" lIns="0" tIns="0" rIns="0" bIns="0" anchor="ctr" anchorCtr="0">
-            <a:noAutofit/>
-          </a:bodyPr>
-          <a:lstStyle/>
-          <a:p>
-            <a:pPr marL="0" marR="0" lvl="0" indent="0" algn="l" rtl="0">
-              <a:lnSpc>
-                <a:spcPct val="140000"/>
-              </a:lnSpc>
-              <a:spcBef>
-                <a:spcPts val="0"/>
-              </a:spcBef>
-              <a:spcAft>
-                <a:spcPts val="0"/>
-              </a:spcAft>
-              <a:buNone/>
-            </a:pPr>
-            <a:r>
-              <a:rPr lang="en-US" sz="3200" dirty="0">
-                <a:solidFill>
-                  <a:srgbClr val="0E0E0E"/>
-                </a:solidFill>
-                <a:latin typeface="Montserrat"/>
-                <a:ea typeface="Montserrat"/>
-                <a:cs typeface="Montserrat"/>
-                <a:sym typeface="Montserrat"/>
-              </a:rPr>
-              <a:t>Canteiro De Obras</a:t>
-            </a:r>
-            <a:endParaRPr sz="3200" dirty="0">
-              <a:latin typeface="Montserrat"/>
-              <a:ea typeface="Montserrat"/>
-              <a:cs typeface="Montserrat"/>
-              <a:sym typeface="Montserrat"/>
-            </a:endParaRPr>
-          </a:p>
-        </p:txBody>
-      </p:sp>
-      <p:sp>
-        <p:nvSpPr>
-          <p:cNvPr id="89" name="Google Shape;89;p13"/>
-          <p:cNvSpPr txBox="1"/>
-          <p:nvPr/>
-        </p:nvSpPr>
-        <p:spPr>
-          <a:xfrm>
-            <a:off x="20729139" y="14617541"/>
-            <a:ext cx="9299100" cy="492600"/>
-          </a:xfrm>
-          <a:prstGeom prst="rect">
-            <a:avLst/>
-          </a:prstGeom>
-          <a:noFill/>
-          <a:ln>
-            <a:noFill/>
-          </a:ln>
-        </p:spPr>
-        <p:txBody>
-          <a:bodyPr spcFirstLastPara="1" wrap="square" lIns="0" tIns="0" rIns="0" bIns="0" anchor="ctr" anchorCtr="0">
-            <a:noAutofit/>
-          </a:bodyPr>
-          <a:lstStyle/>
-          <a:p>
-            <a:pPr marL="0" marR="0" lvl="0" indent="0" algn="l" rtl="0">
-              <a:lnSpc>
-                <a:spcPct val="140007"/>
-              </a:lnSpc>
-              <a:spcBef>
-                <a:spcPts val="0"/>
-              </a:spcBef>
-              <a:spcAft>
-                <a:spcPts val="0"/>
-              </a:spcAft>
-              <a:buNone/>
-            </a:pPr>
-            <a:endParaRPr sz="3200" dirty="0">
-              <a:latin typeface="Montserrat"/>
-              <a:ea typeface="Montserrat"/>
-              <a:cs typeface="Montserrat"/>
-              <a:sym typeface="Montserrat"/>
-            </a:endParaRPr>
-          </a:p>
-        </p:txBody>
-      </p:sp>
-      <p:sp>
-        <p:nvSpPr>
-          <p:cNvPr id="91" name="Google Shape;91;p13"/>
-          <p:cNvSpPr txBox="1"/>
-          <p:nvPr/>
-        </p:nvSpPr>
-        <p:spPr>
-          <a:xfrm>
-            <a:off x="6676291" y="19348444"/>
+            <a:off x="18258503" y="19672909"/>
             <a:ext cx="8728811" cy="1378839"/>
           </a:xfrm>
           <a:prstGeom prst="rect">
@@ -11554,66 +11155,14 @@
           </a:bodyPr>
           <a:lstStyle/>
           <a:p>
-            <a:pPr algn="ctr">
+            <a:pPr lvl="0" algn="ctr">
               <a:lnSpc>
                 <a:spcPct val="139918"/>
               </a:lnSpc>
             </a:pPr>
             <a:r>
-              <a:rPr lang="en-US" sz="3200" b="1" dirty="0">
-                <a:solidFill>
-                  <a:schemeClr val="tx1">
-                    <a:lumMod val="85000"/>
-                    <a:lumOff val="15000"/>
-                  </a:schemeClr>
-                </a:solidFill>
-                <a:latin typeface="Arial" panose="020B0604020202020204" pitchFamily="34" charset="0"/>
-                <a:cs typeface="Arial" panose="020B0604020202020204" pitchFamily="34" charset="0"/>
-                <a:sym typeface="Montserrat"/>
-              </a:rPr>
-              <a:t>João da Silva Santos </a:t>
-            </a:r>
-            <a:r>
-              <a:rPr lang="en-US" sz="3200" b="1" dirty="0" err="1">
-                <a:solidFill>
-                  <a:schemeClr val="tx1">
-                    <a:lumMod val="85000"/>
-                    <a:lumOff val="15000"/>
-                  </a:schemeClr>
-                </a:solidFill>
-                <a:latin typeface="Arial" panose="020B0604020202020204" pitchFamily="34" charset="0"/>
-                <a:cs typeface="Arial" panose="020B0604020202020204" pitchFamily="34" charset="0"/>
-                <a:sym typeface="Montserrat"/>
-              </a:rPr>
-              <a:t/>
-            </a:r>
-            <a:r>
-              <a:rPr lang="en-US" sz="3200" b="1" dirty="0">
-                <a:solidFill>
-                  <a:schemeClr val="tx1">
-                    <a:lumMod val="85000"/>
-                    <a:lumOff val="15000"/>
-                  </a:schemeClr>
-                </a:solidFill>
-                <a:latin typeface="Arial" panose="020B0604020202020204" pitchFamily="34" charset="0"/>
-                <a:cs typeface="Arial" panose="020B0604020202020204" pitchFamily="34" charset="0"/>
-                <a:sym typeface="Montserrat"/>
-              </a:rPr>
-              <a:t> </a:t>
-            </a:r>
-            <a:r>
-              <a:rPr lang="en-US" sz="3200" b="1" dirty="0" err="1">
-                <a:solidFill>
-                  <a:schemeClr val="tx1">
-                    <a:lumMod val="85000"/>
-                    <a:lumOff val="15000"/>
-                  </a:schemeClr>
-                </a:solidFill>
-                <a:latin typeface="Arial" panose="020B0604020202020204" pitchFamily="34" charset="0"/>
-                <a:cs typeface="Arial" panose="020B0604020202020204" pitchFamily="34" charset="0"/>
-                <a:sym typeface="Montserrat"/>
-              </a:rPr>
-              <a:t/>
+              <a:rPr lang="pt-BR" sz="3200" b="1" dirty="0"/>
+              <a:t>Adeylton da Silva Araújo</a:t>
             </a:r>
             <a:r>
               <a:rPr lang="en-US" sz="3200" b="1" dirty="0">
@@ -11642,125 +11191,9 @@
                 <a:sym typeface="Montserrat"/>
               </a:rPr>
             </a:br>
-            <a:r>
-              <a:rPr lang="en-US" sz="3200" b="1" dirty="0">
-                <a:solidFill>
-                  <a:schemeClr val="tx1">
-                    <a:lumMod val="85000"/>
-                    <a:lumOff val="15000"/>
-                  </a:schemeClr>
-                </a:solidFill>
-                <a:latin typeface="Arial" panose="020B0604020202020204" pitchFamily="34" charset="0"/>
-                <a:cs typeface="Arial" panose="020B0604020202020204" pitchFamily="34" charset="0"/>
-                <a:sym typeface="Montserrat"/>
-              </a:rPr>
-              <a:t>CPF: </a:t>
-            </a:r>
-            <a:r>
-              <a:rPr lang="en-US" sz="3200" b="1" dirty="0">
-                <a:solidFill>
-                  <a:schemeClr val="tx1">
-                    <a:lumMod val="85000"/>
-                    <a:lumOff val="15000"/>
-                  </a:schemeClr>
-                </a:solidFill>
-                <a:latin typeface="Montserrat"/>
-                <a:ea typeface="Montserrat"/>
-                <a:cs typeface="Montserrat"/>
-                <a:sym typeface="Montserrat"/>
-              </a:rPr>
-              <a:t>123.456.789-00</a:t>
-            </a:r>
-          </a:p>
-        </p:txBody>
-      </p:sp>
-      <p:pic>
-        <p:nvPicPr>
-          <p:cNvPr id="2" name="Imagem 1"/>
-          <p:cNvPicPr>
-            <a:picLocks noChangeAspect="1"/>
-          </p:cNvPicPr>
-          <p:nvPr/>
-        </p:nvPicPr>
-        <p:blipFill>
-          <a:blip r:embed="rId4">
-            <a:extLst>
-              <a:ext uri="{28A0092B-C50C-407E-A947-70E740481C1C}">
-                <a14:useLocalDpi xmlns:a14="http://schemas.microsoft.com/office/drawing/2010/main" val="0"/>
-              </a:ext>
-            </a:extLst>
-          </a:blip>
-          <a:stretch>
-            <a:fillRect/>
-          </a:stretch>
-        </p:blipFill>
-        <p:spPr>
-          <a:xfrm>
-            <a:off x="19607362" y="18859033"/>
-            <a:ext cx="6003305" cy="2357662"/>
-          </a:xfrm>
-          <a:prstGeom prst="rect">
-            <a:avLst/>
-          </a:prstGeom>
-        </p:spPr>
-      </p:pic>
-      <p:sp>
-        <p:nvSpPr>
-          <p:cNvPr id="4" name="Google Shape;89;p13">
-            <a:extLst>
-              <a:ext uri="{FF2B5EF4-FFF2-40B4-BE49-F238E27FC236}">
-                <a16:creationId xmlns:a16="http://schemas.microsoft.com/office/drawing/2014/main" xmlns="" id="{9C8D90A7-5BC6-93F6-C636-80DB371E0DD5}"/>
-              </a:ext>
-            </a:extLst>
-          </p:cNvPr>
-          <p:cNvSpPr txBox="1"/>
-          <p:nvPr/>
-        </p:nvSpPr>
-        <p:spPr>
-          <a:xfrm>
-            <a:off x="19607362" y="14555829"/>
-            <a:ext cx="9299100" cy="492600"/>
-          </a:xfrm>
-          <a:prstGeom prst="rect">
-            <a:avLst/>
-          </a:prstGeom>
-          <a:noFill/>
-          <a:ln>
-            <a:noFill/>
-          </a:ln>
-        </p:spPr>
-        <p:txBody>
-          <a:bodyPr spcFirstLastPara="1" wrap="square" lIns="0" tIns="0" rIns="0" bIns="0" anchor="ctr" anchorCtr="0">
-            <a:noAutofit/>
-          </a:bodyPr>
-          <a:lstStyle/>
-          <a:p>
-            <a:pPr marL="0" marR="0" lvl="0" indent="0" algn="l" rtl="0">
-              <a:lnSpc>
-                <a:spcPct val="140007"/>
-              </a:lnSpc>
-              <a:spcBef>
-                <a:spcPts val="0"/>
-              </a:spcBef>
-              <a:spcAft>
-                <a:spcPts val="0"/>
-              </a:spcAft>
-              <a:buNone/>
-            </a:pPr>
-            <a:r>
-              <a:rPr lang="pt-BR" sz="3200" dirty="0">
-                <a:latin typeface="Montserrat"/>
-                <a:ea typeface="Montserrat"/>
-                <a:cs typeface="Montserrat"/>
-                <a:sym typeface="Montserrat"/>
-              </a:rPr>
-              <a:t>Empresa Teste LTDA</a:t>
-            </a:r>
-            <a:endParaRPr sz="3200" dirty="0">
-              <a:latin typeface="Montserrat"/>
-              <a:ea typeface="Montserrat"/>
-              <a:cs typeface="Montserrat"/>
-              <a:sym typeface="Montserrat"/>
+            <a:endParaRPr sz="3200" b="1" dirty="0">
+              <a:latin typeface="Arial" panose="020B0604020202020204" pitchFamily="34" charset="0"/>
+              <a:cs typeface="Arial" panose="020B0604020202020204" pitchFamily="34" charset="0"/>
             </a:endParaRPr>
           </a:p>
         </p:txBody>
@@ -11768,7 +11201,7 @@
     </p:spTree>
     <p:extLst>
       <p:ext uri="{BB962C8B-B14F-4D97-AF65-F5344CB8AC3E}">
-        <p14:creationId xmlns:p14="http://schemas.microsoft.com/office/powerpoint/2010/main" val="3930705192"/>
+        <p14:creationId xmlns:p14="http://schemas.microsoft.com/office/powerpoint/2010/main" val="1304343074"/>
       </p:ext>
     </p:extLst>
   </p:cSld>
@@ -11778,13 +11211,13 @@
 </p:sld>
 </file>
 
-<file path=ppt/slides/slide3.xml><?xml version="1.0" encoding="utf-8"?>
+<file path=ppt/slides/slide2.xml><?xml version="1.0" encoding="utf-8"?>
 <p:sld xmlns:a="http://schemas.openxmlformats.org/drawingml/2006/main" xmlns:r="http://schemas.openxmlformats.org/officeDocument/2006/relationships" xmlns:p="http://schemas.openxmlformats.org/presentationml/2006/main">
   <p:cSld>
     <p:bg>
       <p:bgPr>
         <a:blipFill>
-          <a:blip r:embed="rId3">
+          <a:blip r:embed="rId2">
             <a:alphaModFix/>
           </a:blip>
           <a:stretch>
@@ -11894,7 +11327,7 @@
                 <a:cs typeface="Montserrat SemiBold"/>
                 <a:sym typeface="Montserrat SemiBold"/>
               </a:rPr>
-              <a:t>Técnico</a:t>
+              <a:t>Técnico em Segurança do Trabalho</a:t>
             </a:r>
             <a:r>
               <a:rPr lang="en-US" sz="3200" b="1" i="0" u="none" strike="noStrike" cap="none" dirty="0">
@@ -11906,67 +11339,7 @@
                 <a:cs typeface="Montserrat SemiBold"/>
                 <a:sym typeface="Montserrat SemiBold"/>
               </a:rPr>
-              <a:t> </a:t>
-            </a:r>
-            <a:r>
-              <a:rPr lang="en-US" sz="3200" b="1" i="0" u="none" strike="noStrike" cap="none" dirty="0" err="1">
-                <a:solidFill>
-                  <a:srgbClr val="00B050"/>
-                </a:solidFill>
-                <a:latin typeface="Montserrat SemiBold"/>
-                <a:ea typeface="Montserrat SemiBold"/>
-                <a:cs typeface="Montserrat SemiBold"/>
-                <a:sym typeface="Montserrat SemiBold"/>
-              </a:rPr>
-              <a:t>em</a:t>
-            </a:r>
-            <a:r>
-              <a:rPr lang="en-US" sz="3200" b="1" i="0" u="none" strike="noStrike" cap="none" dirty="0">
-                <a:solidFill>
-                  <a:srgbClr val="00B050"/>
-                </a:solidFill>
-                <a:latin typeface="Montserrat SemiBold"/>
-                <a:ea typeface="Montserrat SemiBold"/>
-                <a:cs typeface="Montserrat SemiBold"/>
-                <a:sym typeface="Montserrat SemiBold"/>
-              </a:rPr>
-              <a:t> </a:t>
-            </a:r>
-            <a:r>
-              <a:rPr lang="en-US" sz="3200" b="1" i="0" u="none" strike="noStrike" cap="none" dirty="0" err="1">
-                <a:solidFill>
-                  <a:srgbClr val="00B050"/>
-                </a:solidFill>
-                <a:latin typeface="Montserrat SemiBold"/>
-                <a:ea typeface="Montserrat SemiBold"/>
-                <a:cs typeface="Montserrat SemiBold"/>
-                <a:sym typeface="Montserrat SemiBold"/>
-              </a:rPr>
-              <a:t>Segurança</a:t>
-            </a:r>
-            <a:r>
-              <a:rPr lang="en-US" sz="3200" b="1" i="0" u="none" strike="noStrike" cap="none" dirty="0">
-                <a:solidFill>
-                  <a:srgbClr val="00B050"/>
-                </a:solidFill>
-                <a:latin typeface="Montserrat SemiBold"/>
-                <a:ea typeface="Montserrat SemiBold"/>
-                <a:cs typeface="Montserrat SemiBold"/>
-                <a:sym typeface="Montserrat SemiBold"/>
-              </a:rPr>
-              <a:t> do </a:t>
-            </a:r>
-            <a:r>
-              <a:rPr lang="en-US" sz="3200" b="1" i="0" u="none" strike="noStrike" cap="none" dirty="0" err="1">
-                <a:solidFill>
-                  <a:srgbClr val="00B050"/>
-                </a:solidFill>
-                <a:latin typeface="Montserrat SemiBold"/>
-                <a:ea typeface="Montserrat SemiBold"/>
-                <a:cs typeface="Montserrat SemiBold"/>
-                <a:sym typeface="Montserrat SemiBold"/>
-              </a:rPr>
-              <a:t>Trabalho</a:t>
+              <a:t>   </a:t>
             </a:r>
             <a:endParaRPr sz="3200" b="1" dirty="0">
               <a:solidFill>
@@ -12020,8 +11393,8 @@
         </p:nvSpPr>
         <p:spPr>
           <a:xfrm>
-            <a:off x="4356159" y="7850478"/>
-            <a:ext cx="7295778" cy="763399"/>
+            <a:off x="4356158" y="7850479"/>
+            <a:ext cx="11100151" cy="493648"/>
           </a:xfrm>
           <a:prstGeom prst="rect">
             <a:avLst/>
@@ -12062,8 +11435,8 @@
         </p:nvSpPr>
         <p:spPr>
           <a:xfrm>
-            <a:off x="4865531" y="8613878"/>
-            <a:ext cx="8952069" cy="631360"/>
+            <a:off x="4865531" y="8859736"/>
+            <a:ext cx="10590779" cy="455813"/>
           </a:xfrm>
           <a:prstGeom prst="rect">
             <a:avLst/>
@@ -12111,8 +11484,8 @@
         </p:nvSpPr>
         <p:spPr>
           <a:xfrm>
-            <a:off x="4251158" y="9591045"/>
-            <a:ext cx="7146185" cy="543730"/>
+            <a:off x="4251157" y="9652955"/>
+            <a:ext cx="7295777" cy="385500"/>
           </a:xfrm>
           <a:prstGeom prst="rect">
             <a:avLst/>
@@ -12166,8 +11539,8 @@
         </p:nvSpPr>
         <p:spPr>
           <a:xfrm>
-            <a:off x="4650237" y="10352984"/>
-            <a:ext cx="5842579" cy="674930"/>
+            <a:off x="4652522" y="10351431"/>
+            <a:ext cx="5051918" cy="629954"/>
           </a:xfrm>
           <a:prstGeom prst="rect">
             <a:avLst/>
@@ -12291,8 +11664,8 @@
         </p:nvSpPr>
         <p:spPr>
           <a:xfrm>
-            <a:off x="5064442" y="12036260"/>
-            <a:ext cx="6332901" cy="674930"/>
+            <a:off x="5427406" y="12017266"/>
+            <a:ext cx="10028904" cy="725340"/>
           </a:xfrm>
           <a:prstGeom prst="rect">
             <a:avLst/>
@@ -12308,7 +11681,7 @@
           </a:bodyPr>
           <a:lstStyle/>
           <a:p>
-            <a:pPr marL="0" marR="0" lvl="0" indent="0" algn="ctr" rtl="0">
+            <a:pPr marL="0" marR="0" lvl="0" indent="0" rtl="0">
               <a:lnSpc>
                 <a:spcPct val="140021"/>
               </a:lnSpc>
@@ -12343,8 +11716,8 @@
         </p:nvSpPr>
         <p:spPr>
           <a:xfrm>
-            <a:off x="4042636" y="12988690"/>
-            <a:ext cx="3961412" cy="385500"/>
+            <a:off x="4042635" y="12988690"/>
+            <a:ext cx="9319403" cy="373349"/>
           </a:xfrm>
           <a:prstGeom prst="rect">
             <a:avLst/>
@@ -12409,7 +11782,7 @@
               <a:rPr lang="pt-BR" altLang="ko-KR" sz="3600" b="1" dirty="0">
                 <a:cs typeface="Arial" panose="020B0604020202020204" pitchFamily="34" charset="0"/>
               </a:rPr>
-              <a:t>a) descrição do equipamento e seus componentes;</a:t>
+              <a:t>Linha 1</a:t>
             </a:r>
           </a:p>
           <a:p>
@@ -12426,7 +11799,7 @@
               <a:rPr lang="pt-BR" altLang="ko-KR" sz="3600" b="1" dirty="0">
                 <a:cs typeface="Arial" panose="020B0604020202020204" pitchFamily="34" charset="0"/>
               </a:rPr>
-              <a:t>b) risco ocupacional contra o qual o EPI oferece proteção;</a:t>
+              <a:t>Linha 2</a:t>
             </a:r>
           </a:p>
           <a:p>
@@ -12443,7 +11816,7 @@
               <a:rPr lang="pt-BR" altLang="ko-KR" sz="3600" b="1" dirty="0">
                 <a:cs typeface="Arial" panose="020B0604020202020204" pitchFamily="34" charset="0"/>
               </a:rPr>
-              <a:t>c) restrições e limitações de proteção;</a:t>
+              <a:t>Linha 3</a:t>
             </a:r>
           </a:p>
           <a:p>
@@ -12460,7 +11833,7 @@
               <a:rPr lang="pt-BR" altLang="ko-KR" sz="3600" b="1" dirty="0">
                 <a:cs typeface="Arial" panose="020B0604020202020204" pitchFamily="34" charset="0"/>
               </a:rPr>
-              <a:t>d) forma adequada de uso e ajuste;</a:t>
+              <a:t>Linha 4</a:t>
             </a:r>
           </a:p>
           <a:p>
@@ -12477,7 +11850,7 @@
               <a:rPr lang="pt-BR" altLang="ko-KR" sz="3600" b="1" dirty="0">
                 <a:cs typeface="Arial" panose="020B0604020202020204" pitchFamily="34" charset="0"/>
               </a:rPr>
-              <a:t>e) manutenção e substituição; e</a:t>
+              <a:t>Linha 5</a:t>
             </a:r>
           </a:p>
           <a:p>
@@ -12494,741 +11867,7 @@
               <a:rPr lang="pt-BR" altLang="ko-KR" sz="3600" b="1" dirty="0">
                 <a:cs typeface="Arial" panose="020B0604020202020204" pitchFamily="34" charset="0"/>
               </a:rPr>
-              <a:t>f) cuidados de limpeza, higienização, guarda e conservação.</a:t>
-            </a:r>
-          </a:p>
-        </p:txBody>
-      </p:sp>
-    </p:spTree>
-    <p:extLst>
-      <p:ext uri="{BB962C8B-B14F-4D97-AF65-F5344CB8AC3E}">
-        <p14:creationId xmlns:p14="http://schemas.microsoft.com/office/powerpoint/2010/main" val="2755545827"/>
-      </p:ext>
-    </p:extLst>
-  </p:cSld>
-  <p:clrMapOvr>
-    <a:masterClrMapping/>
-  </p:clrMapOvr>
-</p:sld>
-</file>
-
-<file path=ppt/slides/slide4.xml><?xml version="1.0" encoding="utf-8"?>
-<p:sld xmlns:a="http://schemas.openxmlformats.org/drawingml/2006/main" xmlns:r="http://schemas.openxmlformats.org/officeDocument/2006/relationships" xmlns:p="http://schemas.openxmlformats.org/presentationml/2006/main">
-  <p:cSld>
-    <p:bg>
-      <p:bgPr>
-        <a:blipFill>
-          <a:blip r:embed="rId3">
-            <a:alphaModFix/>
-          </a:blip>
-          <a:stretch>
-            <a:fillRect/>
-          </a:stretch>
-        </a:blipFill>
-        <a:effectLst/>
-      </p:bgPr>
-    </p:bg>
-    <p:spTree>
-      <p:nvGrpSpPr>
-        <p:cNvPr id="1" name="Shape 95"/>
-        <p:cNvGrpSpPr/>
-        <p:nvPr/>
-      </p:nvGrpSpPr>
-      <p:grpSpPr>
-        <a:xfrm>
-          <a:off x="0" y="0"/>
-          <a:ext cx="0" cy="0"/>
-          <a:chOff x="0" y="0"/>
-          <a:chExt cx="0" cy="0"/>
-        </a:xfrm>
-      </p:grpSpPr>
-      <p:sp>
-        <p:nvSpPr>
-          <p:cNvPr id="98" name="Google Shape;98;p14"/>
-          <p:cNvSpPr txBox="1"/>
-          <p:nvPr/>
-        </p:nvSpPr>
-        <p:spPr>
-          <a:xfrm>
-            <a:off x="6200754" y="15729547"/>
-            <a:ext cx="8133600" cy="2154436"/>
-          </a:xfrm>
-          <a:prstGeom prst="rect">
-            <a:avLst/>
-          </a:prstGeom>
-          <a:noFill/>
-          <a:ln>
-            <a:noFill/>
-          </a:ln>
-        </p:spPr>
-        <p:txBody>
-          <a:bodyPr spcFirstLastPara="1" wrap="square" lIns="0" tIns="0" rIns="0" bIns="0" anchor="t" anchorCtr="0">
-            <a:spAutoFit/>
-          </a:bodyPr>
-          <a:lstStyle/>
-          <a:p>
-            <a:pPr marL="0" marR="0" lvl="0" indent="0" algn="l" rtl="0">
-              <a:lnSpc>
-                <a:spcPct val="140090"/>
-              </a:lnSpc>
-              <a:spcBef>
-                <a:spcPts val="0"/>
-              </a:spcBef>
-              <a:spcAft>
-                <a:spcPts val="0"/>
-              </a:spcAft>
-              <a:buNone/>
-            </a:pPr>
-            <a:r>
-              <a:rPr lang="en-US" sz="3600" b="1" i="0" u="none" strike="noStrike" cap="none" dirty="0" err="1">
-                <a:solidFill>
-                  <a:srgbClr val="2A373F"/>
-                </a:solidFill>
-              </a:rPr>
-              <a:t>Adeylton</a:t>
-            </a:r>
-            <a:r>
-              <a:rPr lang="en-US" sz="3600" b="1" i="0" u="none" strike="noStrike" cap="none" dirty="0">
-                <a:solidFill>
-                  <a:srgbClr val="2A373F"/>
-                </a:solidFill>
-              </a:rPr>
-              <a:t> da Silva </a:t>
-            </a:r>
-            <a:r>
-              <a:rPr lang="en-US" sz="3600" b="1" i="0" u="none" strike="noStrike" cap="none" dirty="0" err="1">
-                <a:solidFill>
-                  <a:srgbClr val="2A373F"/>
-                </a:solidFill>
-              </a:rPr>
-              <a:t>Araújo</a:t>
-            </a:r>
-            <a:endParaRPr sz="3600" b="1" dirty="0"/>
-          </a:p>
-          <a:p>
-            <a:pPr marL="0" marR="0" lvl="0" indent="0" algn="l" rtl="0">
-              <a:lnSpc>
-                <a:spcPct val="140098"/>
-              </a:lnSpc>
-              <a:spcBef>
-                <a:spcPts val="0"/>
-              </a:spcBef>
-              <a:spcAft>
-                <a:spcPts val="0"/>
-              </a:spcAft>
-              <a:buNone/>
-            </a:pPr>
-            <a:r>
-              <a:rPr lang="en-US" sz="3200" b="1" i="0" u="none" strike="noStrike" cap="none" dirty="0" err="1">
-                <a:solidFill>
-                  <a:srgbClr val="00B050"/>
-                </a:solidFill>
-                <a:latin typeface="Montserrat SemiBold"/>
-                <a:ea typeface="Montserrat SemiBold"/>
-                <a:cs typeface="Montserrat SemiBold"/>
-                <a:sym typeface="Montserrat SemiBold"/>
-              </a:rPr>
-              <a:t>Técnico</a:t>
-            </a:r>
-            <a:r>
-              <a:rPr lang="en-US" sz="3200" b="1" i="0" u="none" strike="noStrike" cap="none" dirty="0">
-                <a:solidFill>
-                  <a:srgbClr val="00B050"/>
-                </a:solidFill>
-                <a:latin typeface="Montserrat SemiBold"/>
-                <a:ea typeface="Montserrat SemiBold"/>
-                <a:cs typeface="Montserrat SemiBold"/>
-                <a:sym typeface="Montserrat SemiBold"/>
-              </a:rPr>
-              <a:t> </a:t>
-            </a:r>
-            <a:r>
-              <a:rPr lang="en-US" sz="3200" b="1" i="0" u="none" strike="noStrike" cap="none" dirty="0" err="1">
-                <a:solidFill>
-                  <a:srgbClr val="00B050"/>
-                </a:solidFill>
-                <a:latin typeface="Montserrat SemiBold"/>
-                <a:ea typeface="Montserrat SemiBold"/>
-                <a:cs typeface="Montserrat SemiBold"/>
-                <a:sym typeface="Montserrat SemiBold"/>
-              </a:rPr>
-              <a:t>em</a:t>
-            </a:r>
-            <a:r>
-              <a:rPr lang="en-US" sz="3200" b="1" i="0" u="none" strike="noStrike" cap="none" dirty="0">
-                <a:solidFill>
-                  <a:srgbClr val="00B050"/>
-                </a:solidFill>
-                <a:latin typeface="Montserrat SemiBold"/>
-                <a:ea typeface="Montserrat SemiBold"/>
-                <a:cs typeface="Montserrat SemiBold"/>
-                <a:sym typeface="Montserrat SemiBold"/>
-              </a:rPr>
-              <a:t> </a:t>
-            </a:r>
-            <a:r>
-              <a:rPr lang="en-US" sz="3200" b="1" i="0" u="none" strike="noStrike" cap="none" dirty="0" err="1">
-                <a:solidFill>
-                  <a:srgbClr val="00B050"/>
-                </a:solidFill>
-                <a:latin typeface="Montserrat SemiBold"/>
-                <a:ea typeface="Montserrat SemiBold"/>
-                <a:cs typeface="Montserrat SemiBold"/>
-                <a:sym typeface="Montserrat SemiBold"/>
-              </a:rPr>
-              <a:t>Segurança</a:t>
-            </a:r>
-            <a:r>
-              <a:rPr lang="en-US" sz="3200" b="1" i="0" u="none" strike="noStrike" cap="none" dirty="0">
-                <a:solidFill>
-                  <a:srgbClr val="00B050"/>
-                </a:solidFill>
-                <a:latin typeface="Montserrat SemiBold"/>
-                <a:ea typeface="Montserrat SemiBold"/>
-                <a:cs typeface="Montserrat SemiBold"/>
-                <a:sym typeface="Montserrat SemiBold"/>
-              </a:rPr>
-              <a:t> do </a:t>
-            </a:r>
-            <a:r>
-              <a:rPr lang="en-US" sz="3200" b="1" i="0" u="none" strike="noStrike" cap="none" dirty="0" err="1">
-                <a:solidFill>
-                  <a:srgbClr val="00B050"/>
-                </a:solidFill>
-                <a:latin typeface="Montserrat SemiBold"/>
-                <a:ea typeface="Montserrat SemiBold"/>
-                <a:cs typeface="Montserrat SemiBold"/>
-                <a:sym typeface="Montserrat SemiBold"/>
-              </a:rPr>
-              <a:t>Trabalho</a:t>
-            </a:r>
-            <a:endParaRPr sz="3200" b="1" dirty="0">
-              <a:solidFill>
-                <a:srgbClr val="00B050"/>
-              </a:solidFill>
-              <a:latin typeface="Montserrat SemiBold"/>
-              <a:ea typeface="Montserrat SemiBold"/>
-              <a:cs typeface="Montserrat SemiBold"/>
-              <a:sym typeface="Montserrat SemiBold"/>
-            </a:endParaRPr>
-          </a:p>
-          <a:p>
-            <a:pPr marL="0" marR="0" lvl="0" indent="0" algn="l" rtl="0">
-              <a:lnSpc>
-                <a:spcPct val="140070"/>
-              </a:lnSpc>
-              <a:spcBef>
-                <a:spcPts val="0"/>
-              </a:spcBef>
-              <a:spcAft>
-                <a:spcPts val="0"/>
-              </a:spcAft>
-              <a:buNone/>
-            </a:pPr>
-            <a:r>
-              <a:rPr lang="en-US" sz="3200" i="0" u="none" strike="noStrike" cap="none" dirty="0">
-                <a:solidFill>
-                  <a:srgbClr val="494949"/>
-                </a:solidFill>
-                <a:latin typeface="Montserrat SemiBold"/>
-                <a:ea typeface="Montserrat SemiBold"/>
-                <a:cs typeface="Montserrat SemiBold"/>
-                <a:sym typeface="Montserrat SemiBold"/>
-              </a:rPr>
-              <a:t>SRTE N° 0009823/RN</a:t>
-            </a:r>
-            <a:endParaRPr sz="3200" dirty="0">
-              <a:latin typeface="Montserrat SemiBold"/>
-              <a:ea typeface="Montserrat SemiBold"/>
-              <a:cs typeface="Montserrat SemiBold"/>
-              <a:sym typeface="Montserrat SemiBold"/>
-            </a:endParaRPr>
-          </a:p>
-        </p:txBody>
-      </p:sp>
-      <p:sp>
-        <p:nvSpPr>
-          <p:cNvPr id="99" name="Google Shape;99;p14"/>
-          <p:cNvSpPr txBox="1"/>
-          <p:nvPr/>
-        </p:nvSpPr>
-        <p:spPr>
-          <a:xfrm>
-            <a:off x="4356159" y="7850478"/>
-            <a:ext cx="7295778" cy="763399"/>
-          </a:xfrm>
-          <a:prstGeom prst="rect">
-            <a:avLst/>
-          </a:prstGeom>
-          <a:noFill/>
-          <a:ln>
-            <a:noFill/>
-          </a:ln>
-        </p:spPr>
-        <p:txBody>
-          <a:bodyPr spcFirstLastPara="1" wrap="square" lIns="0" tIns="0" rIns="0" bIns="0" anchor="ctr" anchorCtr="0">
-            <a:noAutofit/>
-          </a:bodyPr>
-          <a:lstStyle/>
-          <a:p>
-            <a:pPr lvl="0">
-              <a:lnSpc>
-                <a:spcPct val="140039"/>
-              </a:lnSpc>
-            </a:pPr>
-            <a:r>
-              <a:rPr lang="pt-BR" sz="3200" b="1" dirty="0">
-                <a:latin typeface="Montserrat"/>
-                <a:ea typeface="Montserrat"/>
-                <a:cs typeface="Montserrat"/>
-                <a:sym typeface="Montserrat"/>
-              </a:rPr>
-              <a:t>Treinamento de NR - 06</a:t>
-            </a:r>
-          </a:p>
-        </p:txBody>
-      </p:sp>
-      <p:sp>
-        <p:nvSpPr>
-          <p:cNvPr id="100" name="Google Shape;100;p14"/>
-          <p:cNvSpPr txBox="1"/>
-          <p:nvPr/>
-        </p:nvSpPr>
-        <p:spPr>
-          <a:xfrm>
-            <a:off x="4865531" y="8859737"/>
-            <a:ext cx="9002869" cy="385500"/>
-          </a:xfrm>
-          <a:prstGeom prst="rect">
-            <a:avLst/>
-          </a:prstGeom>
-          <a:noFill/>
-          <a:ln>
-            <a:noFill/>
-          </a:ln>
-        </p:spPr>
-        <p:txBody>
-          <a:bodyPr spcFirstLastPara="1" wrap="square" lIns="0" tIns="0" rIns="0" bIns="0" anchor="ctr" anchorCtr="0">
-            <a:noAutofit/>
-          </a:bodyPr>
-          <a:lstStyle/>
-          <a:p>
-            <a:pPr marL="0" marR="0" lvl="0" indent="0" algn="l" rtl="0">
-              <a:lnSpc>
-                <a:spcPct val="140007"/>
-              </a:lnSpc>
-              <a:spcBef>
-                <a:spcPts val="0"/>
-              </a:spcBef>
-              <a:spcAft>
-                <a:spcPts val="0"/>
-              </a:spcAft>
-              <a:buNone/>
-            </a:pPr>
-            <a:r>
-              <a:rPr lang="pt-BR" sz="3200" b="1" dirty="0">
-                <a:latin typeface="Montserrat"/>
-                <a:ea typeface="Montserrat"/>
-                <a:cs typeface="Montserrat"/>
-                <a:sym typeface="Montserrat"/>
-              </a:rPr>
-              <a:t>Empresa Teste LTDA</a:t>
-            </a:r>
-          </a:p>
-        </p:txBody>
-      </p:sp>
-      <p:sp>
-        <p:nvSpPr>
-          <p:cNvPr id="101" name="Google Shape;101;p14"/>
-          <p:cNvSpPr txBox="1"/>
-          <p:nvPr/>
-        </p:nvSpPr>
-        <p:spPr>
-          <a:xfrm>
-            <a:off x="4251157" y="9652955"/>
-            <a:ext cx="7295777" cy="385500"/>
-          </a:xfrm>
-          <a:prstGeom prst="rect">
-            <a:avLst/>
-          </a:prstGeom>
-          <a:noFill/>
-          <a:ln>
-            <a:noFill/>
-          </a:ln>
-        </p:spPr>
-        <p:txBody>
-          <a:bodyPr spcFirstLastPara="1" wrap="square" lIns="0" tIns="0" rIns="0" bIns="0" anchor="ctr" anchorCtr="0">
-            <a:noAutofit/>
-          </a:bodyPr>
-          <a:lstStyle/>
-          <a:p>
-            <a:pPr marL="0" marR="0" lvl="0" indent="0" algn="l" rtl="0">
-              <a:lnSpc>
-                <a:spcPct val="140039"/>
-              </a:lnSpc>
-              <a:spcBef>
-                <a:spcPts val="0"/>
-              </a:spcBef>
-              <a:spcAft>
-                <a:spcPts val="0"/>
-              </a:spcAft>
-              <a:buNone/>
-            </a:pPr>
-            <a:r>
-              <a:rPr lang="en-US" sz="3200" b="1" dirty="0">
-                <a:latin typeface="Montserrat"/>
-                <a:ea typeface="Montserrat"/>
-                <a:cs typeface="Montserrat"/>
-                <a:sym typeface="Montserrat"/>
-              </a:rPr>
-              <a:t>Canteiro De Obras</a:t>
-            </a:r>
-            <a:endParaRPr sz="3200" b="1" dirty="0">
-              <a:latin typeface="Montserrat"/>
-              <a:ea typeface="Montserrat"/>
-              <a:cs typeface="Montserrat"/>
-              <a:sym typeface="Montserrat"/>
-            </a:endParaRPr>
-          </a:p>
-        </p:txBody>
-      </p:sp>
-      <p:sp>
-        <p:nvSpPr>
-          <p:cNvPr id="102" name="Google Shape;102;p14"/>
-          <p:cNvSpPr txBox="1"/>
-          <p:nvPr/>
-        </p:nvSpPr>
-        <p:spPr>
-          <a:xfrm>
-            <a:off x="4652521" y="10351431"/>
-            <a:ext cx="5232979" cy="674930"/>
-          </a:xfrm>
-          <a:prstGeom prst="rect">
-            <a:avLst/>
-          </a:prstGeom>
-          <a:noFill/>
-          <a:ln>
-            <a:noFill/>
-          </a:ln>
-        </p:spPr>
-        <p:txBody>
-          <a:bodyPr spcFirstLastPara="1" wrap="square" lIns="0" tIns="0" rIns="0" bIns="0" anchor="ctr" anchorCtr="0">
-            <a:noAutofit/>
-          </a:bodyPr>
-          <a:lstStyle/>
-          <a:p>
-            <a:pPr marL="0" marR="0" lvl="0" indent="0" algn="l" rtl="0">
-              <a:lnSpc>
-                <a:spcPct val="140039"/>
-              </a:lnSpc>
-              <a:spcBef>
-                <a:spcPts val="0"/>
-              </a:spcBef>
-              <a:spcAft>
-                <a:spcPts val="0"/>
-              </a:spcAft>
-              <a:buNone/>
-            </a:pPr>
-            <a:r>
-              <a:rPr lang="en-US" sz="3200" b="1" dirty="0">
-                <a:latin typeface="Montserrat"/>
-                <a:ea typeface="Montserrat"/>
-                <a:cs typeface="Montserrat"/>
-                <a:sym typeface="Montserrat"/>
-              </a:rPr>
-              <a:t>07</a:t>
-            </a:r>
-            <a:r>
-              <a:rPr lang="en-US" sz="3200" b="1" i="0" u="none" strike="noStrike" cap="none" dirty="0">
-                <a:solidFill>
-                  <a:srgbClr val="000000"/>
-                </a:solidFill>
-                <a:latin typeface="Montserrat"/>
-                <a:ea typeface="Montserrat"/>
-                <a:cs typeface="Montserrat"/>
-                <a:sym typeface="Montserrat"/>
-              </a:rPr>
-              <a:t>/08/2026</a:t>
-            </a:r>
-            <a:endParaRPr sz="3200" b="1" dirty="0">
-              <a:latin typeface="Montserrat"/>
-              <a:ea typeface="Montserrat"/>
-              <a:cs typeface="Montserrat"/>
-              <a:sym typeface="Montserrat"/>
-            </a:endParaRPr>
-          </a:p>
-        </p:txBody>
-      </p:sp>
-      <p:sp>
-        <p:nvSpPr>
-          <p:cNvPr id="103" name="Google Shape;103;p14"/>
-          <p:cNvSpPr txBox="1"/>
-          <p:nvPr/>
-        </p:nvSpPr>
-        <p:spPr>
-          <a:xfrm>
-            <a:off x="5731962" y="11339337"/>
-            <a:ext cx="1452900" cy="385500"/>
-          </a:xfrm>
-          <a:prstGeom prst="rect">
-            <a:avLst/>
-          </a:prstGeom>
-          <a:noFill/>
-          <a:ln>
-            <a:noFill/>
-          </a:ln>
-        </p:spPr>
-        <p:txBody>
-          <a:bodyPr spcFirstLastPara="1" wrap="square" lIns="0" tIns="0" rIns="0" bIns="0" anchor="ctr" anchorCtr="0">
-            <a:noAutofit/>
-          </a:bodyPr>
-          <a:lstStyle/>
-          <a:p>
-            <a:pPr marL="0" marR="0" lvl="0" indent="0" algn="l" rtl="0">
-              <a:lnSpc>
-                <a:spcPct val="140039"/>
-              </a:lnSpc>
-              <a:spcBef>
-                <a:spcPts val="0"/>
-              </a:spcBef>
-              <a:spcAft>
-                <a:spcPts val="0"/>
-              </a:spcAft>
-              <a:buNone/>
-            </a:pPr>
-            <a:r>
-              <a:rPr lang="en-US" sz="3200" b="1" i="0" u="none" strike="noStrike" cap="none" dirty="0">
-                <a:solidFill>
-                  <a:srgbClr val="000000"/>
-                </a:solidFill>
-                <a:latin typeface="Montserrat"/>
-                <a:ea typeface="Montserrat"/>
-                <a:cs typeface="Montserrat"/>
-                <a:sym typeface="Montserrat"/>
-              </a:rPr>
-              <a:t>1 hora</a:t>
-            </a:r>
-            <a:endParaRPr sz="3200" b="1" dirty="0">
-              <a:latin typeface="Montserrat"/>
-              <a:ea typeface="Montserrat"/>
-              <a:cs typeface="Montserrat"/>
-              <a:sym typeface="Montserrat"/>
-            </a:endParaRPr>
-          </a:p>
-        </p:txBody>
-      </p:sp>
-      <p:sp>
-        <p:nvSpPr>
-          <p:cNvPr id="104" name="Google Shape;104;p14"/>
-          <p:cNvSpPr txBox="1"/>
-          <p:nvPr/>
-        </p:nvSpPr>
-        <p:spPr>
-          <a:xfrm>
-            <a:off x="5064442" y="12017266"/>
-            <a:ext cx="6332901" cy="674930"/>
-          </a:xfrm>
-          <a:prstGeom prst="rect">
-            <a:avLst/>
-          </a:prstGeom>
-          <a:noFill/>
-          <a:ln>
-            <a:noFill/>
-          </a:ln>
-        </p:spPr>
-        <p:txBody>
-          <a:bodyPr spcFirstLastPara="1" wrap="square" lIns="0" tIns="0" rIns="0" bIns="0" anchor="ctr" anchorCtr="0">
-            <a:noAutofit/>
-          </a:bodyPr>
-          <a:lstStyle/>
-          <a:p>
-            <a:pPr marL="0" marR="0" lvl="0" indent="0" algn="ctr" rtl="0">
-              <a:lnSpc>
-                <a:spcPct val="140021"/>
-              </a:lnSpc>
-              <a:spcBef>
-                <a:spcPts val="0"/>
-              </a:spcBef>
-              <a:spcAft>
-                <a:spcPts val="0"/>
-              </a:spcAft>
-              <a:buNone/>
-            </a:pPr>
-            <a:r>
-              <a:rPr lang="en-US" sz="3200" b="1" dirty="0">
-                <a:solidFill>
-                  <a:schemeClr val="dk1"/>
-                </a:solidFill>
-                <a:latin typeface="Montserrat"/>
-                <a:ea typeface="Montserrat"/>
-                <a:cs typeface="Montserrat"/>
-                <a:sym typeface="Montserrat"/>
-              </a:rPr>
-              <a:t>João da Silva Santos</a:t>
-            </a:r>
-          </a:p>
-        </p:txBody>
-      </p:sp>
-      <p:sp>
-        <p:nvSpPr>
-          <p:cNvPr id="105" name="Google Shape;105;p14"/>
-          <p:cNvSpPr txBox="1"/>
-          <p:nvPr/>
-        </p:nvSpPr>
-        <p:spPr>
-          <a:xfrm>
-            <a:off x="4042636" y="12988690"/>
-            <a:ext cx="3961412" cy="385500"/>
-          </a:xfrm>
-          <a:prstGeom prst="rect">
-            <a:avLst/>
-          </a:prstGeom>
-          <a:noFill/>
-          <a:ln>
-            <a:noFill/>
-          </a:ln>
-        </p:spPr>
-        <p:txBody>
-          <a:bodyPr spcFirstLastPara="1" wrap="square" lIns="0" tIns="0" rIns="0" bIns="0" anchor="ctr" anchorCtr="0">
-            <a:noAutofit/>
-          </a:bodyPr>
-          <a:lstStyle/>
-          <a:p>
-            <a:pPr lvl="0">
-              <a:lnSpc>
-                <a:spcPct val="140039"/>
-              </a:lnSpc>
-            </a:pPr>
-            <a:r>
-              <a:rPr lang="en-US" sz="3200" b="1" dirty="0">
-                <a:latin typeface="Montserrat"/>
-                <a:ea typeface="Montserrat"/>
-                <a:cs typeface="Montserrat"/>
-                <a:sym typeface="Montserrat"/>
-              </a:rPr>
-              <a:t>123.456.789-00</a:t>
-            </a:r>
-          </a:p>
-        </p:txBody>
-      </p:sp>
-      <p:sp>
-        <p:nvSpPr>
-          <p:cNvPr id="11" name="TextBox 8">
-            <a:extLst>
-              <a:ext uri="{FF2B5EF4-FFF2-40B4-BE49-F238E27FC236}">
-                <a16:creationId xmlns:a16="http://schemas.microsoft.com/office/drawing/2014/main" xmlns="" id="{31A90F8C-A50F-56F6-6B1F-D67AFB17A276}"/>
-              </a:ext>
-            </a:extLst>
-          </p:cNvPr>
-          <p:cNvSpPr txBox="1"/>
-          <p:nvPr/>
-        </p:nvSpPr>
-        <p:spPr>
-          <a:xfrm>
-            <a:off x="17409186" y="7643901"/>
-            <a:ext cx="13680413" cy="6186309"/>
-          </a:xfrm>
-          <a:prstGeom prst="rect">
-            <a:avLst/>
-          </a:prstGeom>
-          <a:noFill/>
-        </p:spPr>
-        <p:txBody>
-          <a:bodyPr wrap="square" rtlCol="0" anchor="ctr">
-            <a:spAutoFit/>
-          </a:bodyPr>
-          <a:lstStyle/>
-          <a:p>
-            <a:r>
-              <a:rPr lang="pt-BR" altLang="ko-KR" sz="3600" b="1" dirty="0">
-                <a:cs typeface="Arial" panose="020B0604020202020204" pitchFamily="34" charset="0"/>
-              </a:rPr>
-              <a:t>a) descrição do equipamento e seus componentes;</a:t>
-            </a:r>
-          </a:p>
-          <a:p>
-            <a:pPr marL="250603" indent="-250603">
-              <a:buFont typeface="Wingdings" panose="05000000000000000000" pitchFamily="2" charset="2"/>
-              <a:buChar char="ü"/>
-            </a:pPr>
-            <a:endParaRPr lang="pt-BR" altLang="ko-KR" sz="3600" b="1" dirty="0">
-              <a:cs typeface="Arial" panose="020B0604020202020204" pitchFamily="34" charset="0"/>
-            </a:endParaRPr>
-          </a:p>
-          <a:p>
-            <a:r>
-              <a:rPr lang="pt-BR" altLang="ko-KR" sz="3600" b="1" dirty="0">
-                <a:cs typeface="Arial" panose="020B0604020202020204" pitchFamily="34" charset="0"/>
-              </a:rPr>
-              <a:t>b) risco ocupacional contra o qual o EPI oferece proteção;</a:t>
-            </a:r>
-          </a:p>
-          <a:p>
-            <a:pPr marL="250603" indent="-250603">
-              <a:buFont typeface="Wingdings" panose="05000000000000000000" pitchFamily="2" charset="2"/>
-              <a:buChar char="ü"/>
-            </a:pPr>
-            <a:endParaRPr lang="pt-BR" altLang="ko-KR" sz="3600" b="1" dirty="0">
-              <a:cs typeface="Arial" panose="020B0604020202020204" pitchFamily="34" charset="0"/>
-            </a:endParaRPr>
-          </a:p>
-          <a:p>
-            <a:r>
-              <a:rPr lang="pt-BR" altLang="ko-KR" sz="3600" b="1" dirty="0">
-                <a:cs typeface="Arial" panose="020B0604020202020204" pitchFamily="34" charset="0"/>
-              </a:rPr>
-              <a:t>c) restrições e limitações de proteção;</a:t>
-            </a:r>
-          </a:p>
-          <a:p>
-            <a:pPr marL="250603" indent="-250603">
-              <a:buFont typeface="Wingdings" panose="05000000000000000000" pitchFamily="2" charset="2"/>
-              <a:buChar char="ü"/>
-            </a:pPr>
-            <a:endParaRPr lang="pt-BR" altLang="ko-KR" sz="3600" b="1" dirty="0">
-              <a:cs typeface="Arial" panose="020B0604020202020204" pitchFamily="34" charset="0"/>
-            </a:endParaRPr>
-          </a:p>
-          <a:p>
-            <a:r>
-              <a:rPr lang="pt-BR" altLang="ko-KR" sz="3600" b="1" dirty="0">
-                <a:cs typeface="Arial" panose="020B0604020202020204" pitchFamily="34" charset="0"/>
-              </a:rPr>
-              <a:t>d) forma adequada de uso e ajuste;</a:t>
-            </a:r>
-          </a:p>
-          <a:p>
-            <a:pPr marL="250603" indent="-250603">
-              <a:buFont typeface="Wingdings" panose="05000000000000000000" pitchFamily="2" charset="2"/>
-              <a:buChar char="ü"/>
-            </a:pPr>
-            <a:endParaRPr lang="pt-BR" altLang="ko-KR" sz="3600" b="1" dirty="0">
-              <a:cs typeface="Arial" panose="020B0604020202020204" pitchFamily="34" charset="0"/>
-            </a:endParaRPr>
-          </a:p>
-          <a:p>
-            <a:r>
-              <a:rPr lang="pt-BR" altLang="ko-KR" sz="3600" b="1" dirty="0">
-                <a:cs typeface="Arial" panose="020B0604020202020204" pitchFamily="34" charset="0"/>
-              </a:rPr>
-              <a:t>e) manutenção e substituição; e</a:t>
-            </a:r>
-          </a:p>
-          <a:p>
-            <a:pPr marL="250603" indent="-250603">
-              <a:buFont typeface="Wingdings" panose="05000000000000000000" pitchFamily="2" charset="2"/>
-              <a:buChar char="ü"/>
-            </a:pPr>
-            <a:endParaRPr lang="pt-BR" altLang="ko-KR" sz="3600" b="1" dirty="0">
-              <a:cs typeface="Arial" panose="020B0604020202020204" pitchFamily="34" charset="0"/>
-            </a:endParaRPr>
-          </a:p>
-          <a:p>
-            <a:r>
-              <a:rPr lang="pt-BR" altLang="ko-KR" sz="3600" b="1" dirty="0">
-                <a:cs typeface="Arial" panose="020B0604020202020204" pitchFamily="34" charset="0"/>
-              </a:rPr>
-              <a:t>f) cuidados de limpeza, higienização, guarda e conservação.</a:t>
+              <a:t>Linha 6</a:t>
             </a:r>
           </a:p>
         </p:txBody>

</xml_diff>